<commit_message>
Adiciona relatório Equatorial Telecom de setembro/2026 e corrige exportação PPTX
- Relatório HTML, PDF e PPTX da Equatorial Telecom com base no modelo de agosto
- PPTX: títulos entre listas deixam de ser mesclados numa só caixa de texto (todos os relatórios regenerados)

Co-Authored-By: Claude Opus 5.5 <noreply@anthropic.com>
Claude-Session: https://claude.ai/code/session_018aor3gsZX6WscNn4yXKg1c
</commit_message>
<xml_diff>
--- a/relatorios/maximize/pptx/echo-enova-setembro-2026.pptx
+++ b/relatorios/maximize/pptx/echo-enova-setembro-2026.pptx
@@ -27298,7 +27298,77 @@
         <p:spPr>
           <a:xfrm>
             <a:off x="428625" y="1409700"/>
-            <a:ext cx="5690235" cy="1107281"/>
+            <a:ext cx="1228279" cy="133350"/>
+          </a:xfrm>
+          <a:prstGeom prst="rect">
+            <a:avLst/>
+          </a:prstGeom>
+          <a:noFill/>
+        </p:spPr>
+        <p:txBody>
+          <a:bodyPr wrap="none" lIns="0" rIns="0" tIns="0" bIns="0" anchor="t">
+            <a:noAutofit/>
+          </a:bodyPr>
+          <a:lstStyle/>
+          <a:p>
+            <a:pPr algn="l"/>
+            <a:r>
+              <a:rPr sz="850" b="1" i="0">
+                <a:solidFill>
+                  <a:srgbClr val="000000"/>
+                </a:solidFill>
+                <a:latin typeface="Montserrat"/>
+              </a:rPr>
+              <a:t>Alcance e Interações</a:t>
+            </a:r>
+          </a:p>
+        </p:txBody>
+      </p:sp>
+      <p:sp>
+        <p:nvSpPr>
+          <p:cNvPr id="10" name="TextBox 9"/>
+          <p:cNvSpPr txBox="1"/>
+          <p:nvPr/>
+        </p:nvSpPr>
+        <p:spPr>
+          <a:xfrm>
+            <a:off x="428625" y="2383631"/>
+            <a:ext cx="1646634" cy="133350"/>
+          </a:xfrm>
+          <a:prstGeom prst="rect">
+            <a:avLst/>
+          </a:prstGeom>
+          <a:noFill/>
+        </p:spPr>
+        <p:txBody>
+          <a:bodyPr wrap="none" lIns="0" rIns="0" tIns="0" bIns="0" anchor="t">
+            <a:noAutofit/>
+          </a:bodyPr>
+          <a:lstStyle/>
+          <a:p>
+            <a:pPr algn="l"/>
+            <a:r>
+              <a:rPr sz="850" b="1" i="0">
+                <a:solidFill>
+                  <a:srgbClr val="000000"/>
+                </a:solidFill>
+                <a:latin typeface="Montserrat"/>
+              </a:rPr>
+              <a:t>Crescimento de Seguidores:</a:t>
+            </a:r>
+          </a:p>
+        </p:txBody>
+      </p:sp>
+      <p:sp>
+        <p:nvSpPr>
+          <p:cNvPr id="11" name="TextBox 10"/>
+          <p:cNvSpPr txBox="1"/>
+          <p:nvPr/>
+        </p:nvSpPr>
+        <p:spPr>
+          <a:xfrm>
+            <a:off x="600075" y="1574006"/>
+            <a:ext cx="5513642" cy="297656"/>
           </a:xfrm>
           <a:prstGeom prst="rect">
             <a:avLst/>
@@ -27317,35 +27387,44 @@
               </a:lnSpc>
             </a:pPr>
             <a:r>
+              <a:rPr sz="850" b="0" i="0">
+                <a:solidFill>
+                  <a:srgbClr val="000000"/>
+                </a:solidFill>
+                <a:latin typeface="Montserrat"/>
+              </a:rPr>
+              <a:t>• </a:t>
+            </a:r>
+            <a:r>
               <a:rPr sz="850" b="1" i="0">
                 <a:solidFill>
                   <a:srgbClr val="000000"/>
                 </a:solidFill>
                 <a:latin typeface="Montserrat"/>
               </a:rPr>
-              <a:t>Alcance e Interações</a:t>
-            </a:r>
-            <a:r>
-              <a:rPr sz="850" b="1" i="0">
-                <a:solidFill>
-                  <a:srgbClr val="000000"/>
-                </a:solidFill>
-                <a:latin typeface="Montserrat"/>
-              </a:rPr>
-              <a:t>Crescimento de Seguidores:</a:t>
-            </a:r>
-          </a:p>
-        </p:txBody>
-      </p:sp>
-      <p:sp>
-        <p:nvSpPr>
-          <p:cNvPr id="10" name="TextBox 9"/>
-          <p:cNvSpPr txBox="1"/>
-          <p:nvPr/>
-        </p:nvSpPr>
-        <p:spPr>
-          <a:xfrm>
-            <a:off x="600075" y="1574006"/>
+              <a:t>Instagram:</a:t>
+            </a:r>
+            <a:r>
+              <a:rPr sz="850" b="0" i="0">
+                <a:solidFill>
+                  <a:srgbClr val="000000"/>
+                </a:solidFill>
+                <a:latin typeface="Montserrat"/>
+              </a:rPr>
+              <a:t> -10% no alcance e -22% nas interações, com taxa de engajamento estável (3,8%), visitas ao perfil +8% e cliques no link +85%; collab com o Grupo Equatorial foi o maior destaque do mês;</a:t>
+            </a:r>
+          </a:p>
+        </p:txBody>
+      </p:sp>
+      <p:sp>
+        <p:nvSpPr>
+          <p:cNvPr id="12" name="TextBox 11"/>
+          <p:cNvSpPr txBox="1"/>
+          <p:nvPr/>
+        </p:nvSpPr>
+        <p:spPr>
+          <a:xfrm>
+            <a:off x="600075" y="1978819"/>
             <a:ext cx="5513642" cy="297656"/>
           </a:xfrm>
           <a:prstGeom prst="rect">
@@ -27380,6 +27459,59 @@
                 </a:solidFill>
                 <a:latin typeface="Montserrat"/>
               </a:rPr>
+              <a:t>LinkedIn:</a:t>
+            </a:r>
+            <a:r>
+              <a:rPr sz="850" b="0" i="0">
+                <a:solidFill>
+                  <a:srgbClr val="000000"/>
+                </a:solidFill>
+                <a:latin typeface="Montserrat"/>
+              </a:rPr>
+              <a:t> -10% nos visitantes únicos e -46% nas interações, com mês concentrado em agendas institucionais e destaque para conteúdos com colaboradores.</a:t>
+            </a:r>
+          </a:p>
+        </p:txBody>
+      </p:sp>
+      <p:sp>
+        <p:nvSpPr>
+          <p:cNvPr id="13" name="TextBox 12"/>
+          <p:cNvSpPr txBox="1"/>
+          <p:nvPr/>
+        </p:nvSpPr>
+        <p:spPr>
+          <a:xfrm>
+            <a:off x="600075" y="2547938"/>
+            <a:ext cx="5338316" cy="133350"/>
+          </a:xfrm>
+          <a:prstGeom prst="rect">
+            <a:avLst/>
+          </a:prstGeom>
+          <a:noFill/>
+        </p:spPr>
+        <p:txBody>
+          <a:bodyPr wrap="none" lIns="0" rIns="0" tIns="0" bIns="0" anchor="t">
+            <a:noAutofit/>
+          </a:bodyPr>
+          <a:lstStyle/>
+          <a:p>
+            <a:pPr algn="l"/>
+            <a:r>
+              <a:rPr sz="850" b="0" i="0">
+                <a:solidFill>
+                  <a:srgbClr val="000000"/>
+                </a:solidFill>
+                <a:latin typeface="Montserrat"/>
+              </a:rPr>
+              <a:t>• </a:t>
+            </a:r>
+            <a:r>
+              <a:rPr sz="850" b="1" i="0">
+                <a:solidFill>
+                  <a:srgbClr val="000000"/>
+                </a:solidFill>
+                <a:latin typeface="Montserrat"/>
+              </a:rPr>
               <a:t>Instagram:</a:t>
             </a:r>
             <a:r>
@@ -27389,20 +27521,20 @@
                 </a:solidFill>
                 <a:latin typeface="Montserrat"/>
               </a:rPr>
-              <a:t> -10% no alcance e -22% nas interações, com taxa de engajamento estável (3,8%), visitas ao perfil +8% e cliques no link +85%; collab com o Grupo Equatorial foi o maior destaque do mês;</a:t>
-            </a:r>
-          </a:p>
-        </p:txBody>
-      </p:sp>
-      <p:sp>
-        <p:nvSpPr>
-          <p:cNvPr id="11" name="TextBox 10"/>
-          <p:cNvSpPr txBox="1"/>
-          <p:nvPr/>
-        </p:nvSpPr>
-        <p:spPr>
-          <a:xfrm>
-            <a:off x="600075" y="1978819"/>
+              <a:t> +91 seguidores, encerrando o período com 16.116 seguidores e taxa de retenção de 7%;</a:t>
+            </a:r>
+          </a:p>
+        </p:txBody>
+      </p:sp>
+      <p:sp>
+        <p:nvSpPr>
+          <p:cNvPr id="14" name="TextBox 13"/>
+          <p:cNvSpPr txBox="1"/>
+          <p:nvPr/>
+        </p:nvSpPr>
+        <p:spPr>
+          <a:xfrm>
+            <a:off x="600075" y="2788444"/>
             <a:ext cx="5513642" cy="297656"/>
           </a:xfrm>
           <a:prstGeom prst="rect">
@@ -27446,21 +27578,21 @@
                 </a:solidFill>
                 <a:latin typeface="Montserrat"/>
               </a:rPr>
-              <a:t> -10% nos visitantes únicos e -46% nas interações, com mês concentrado em agendas institucionais e destaque para conteúdos com colaboradores.</a:t>
-            </a:r>
-          </a:p>
-        </p:txBody>
-      </p:sp>
-      <p:sp>
-        <p:nvSpPr>
-          <p:cNvPr id="12" name="TextBox 11"/>
-          <p:cNvSpPr txBox="1"/>
-          <p:nvPr/>
-        </p:nvSpPr>
-        <p:spPr>
-          <a:xfrm>
-            <a:off x="600075" y="2547938"/>
-            <a:ext cx="5338316" cy="133350"/>
+              <a:t> +567 novos seguidores, finalizando o período com 82.780 seguidores e taxa de retenção de 26%.</a:t>
+            </a:r>
+          </a:p>
+        </p:txBody>
+      </p:sp>
+      <p:sp>
+        <p:nvSpPr>
+          <p:cNvPr id="15" name="TextBox 14"/>
+          <p:cNvSpPr txBox="1"/>
+          <p:nvPr/>
+        </p:nvSpPr>
+        <p:spPr>
+          <a:xfrm>
+            <a:off x="6296025" y="1409700"/>
+            <a:ext cx="1228279" cy="133350"/>
           </a:xfrm>
           <a:prstGeom prst="rect">
             <a:avLst/>
@@ -27475,44 +27607,61 @@
           <a:p>
             <a:pPr algn="l"/>
             <a:r>
-              <a:rPr sz="850" b="0" i="0">
-                <a:solidFill>
-                  <a:srgbClr val="000000"/>
-                </a:solidFill>
-                <a:latin typeface="Montserrat"/>
-              </a:rPr>
-              <a:t>• </a:t>
-            </a:r>
-            <a:r>
               <a:rPr sz="850" b="1" i="0">
                 <a:solidFill>
                   <a:srgbClr val="000000"/>
                 </a:solidFill>
                 <a:latin typeface="Montserrat"/>
               </a:rPr>
-              <a:t>Instagram:</a:t>
-            </a:r>
-            <a:r>
-              <a:rPr sz="850" b="0" i="0">
-                <a:solidFill>
-                  <a:srgbClr val="000000"/>
-                </a:solidFill>
-                <a:latin typeface="Montserrat"/>
-              </a:rPr>
-              <a:t> +91 seguidores, encerrando o período com 16.116 seguidores e taxa de retenção de 7%;</a:t>
-            </a:r>
-          </a:p>
-        </p:txBody>
-      </p:sp>
-      <p:sp>
-        <p:nvSpPr>
-          <p:cNvPr id="13" name="TextBox 12"/>
-          <p:cNvSpPr txBox="1"/>
-          <p:nvPr/>
-        </p:nvSpPr>
-        <p:spPr>
-          <a:xfrm>
-            <a:off x="600075" y="2788444"/>
+              <a:t>Alcance e Interações</a:t>
+            </a:r>
+          </a:p>
+        </p:txBody>
+      </p:sp>
+      <p:sp>
+        <p:nvSpPr>
+          <p:cNvPr id="16" name="TextBox 15"/>
+          <p:cNvSpPr txBox="1"/>
+          <p:nvPr/>
+        </p:nvSpPr>
+        <p:spPr>
+          <a:xfrm>
+            <a:off x="6296025" y="2383631"/>
+            <a:ext cx="1646634" cy="133350"/>
+          </a:xfrm>
+          <a:prstGeom prst="rect">
+            <a:avLst/>
+          </a:prstGeom>
+          <a:noFill/>
+        </p:spPr>
+        <p:txBody>
+          <a:bodyPr wrap="none" lIns="0" rIns="0" tIns="0" bIns="0" anchor="t">
+            <a:noAutofit/>
+          </a:bodyPr>
+          <a:lstStyle/>
+          <a:p>
+            <a:pPr algn="l"/>
+            <a:r>
+              <a:rPr sz="850" b="1" i="0">
+                <a:solidFill>
+                  <a:srgbClr val="000000"/>
+                </a:solidFill>
+                <a:latin typeface="Montserrat"/>
+              </a:rPr>
+              <a:t>Crescimento de Seguidores:</a:t>
+            </a:r>
+          </a:p>
+        </p:txBody>
+      </p:sp>
+      <p:sp>
+        <p:nvSpPr>
+          <p:cNvPr id="17" name="TextBox 16"/>
+          <p:cNvSpPr txBox="1"/>
+          <p:nvPr/>
+        </p:nvSpPr>
+        <p:spPr>
+          <a:xfrm>
+            <a:off x="6467475" y="1574006"/>
             <a:ext cx="5513642" cy="297656"/>
           </a:xfrm>
           <a:prstGeom prst="rect">
@@ -27547,7 +27696,7 @@
                 </a:solidFill>
                 <a:latin typeface="Montserrat"/>
               </a:rPr>
-              <a:t>LinkedIn:</a:t>
+              <a:t>Instagram:</a:t>
             </a:r>
             <a:r>
               <a:rPr sz="850" b="0" i="0">
@@ -27556,21 +27705,21 @@
                 </a:solidFill>
                 <a:latin typeface="Montserrat"/>
               </a:rPr>
-              <a:t> +567 novos seguidores, finalizando o período com 82.780 seguidores e taxa de retenção de 26%.</a:t>
-            </a:r>
-          </a:p>
-        </p:txBody>
-      </p:sp>
-      <p:sp>
-        <p:nvSpPr>
-          <p:cNvPr id="14" name="TextBox 13"/>
-          <p:cNvSpPr txBox="1"/>
-          <p:nvPr/>
-        </p:nvSpPr>
-        <p:spPr>
-          <a:xfrm>
-            <a:off x="6296025" y="1409700"/>
-            <a:ext cx="5690235" cy="1107281"/>
+              <a:t> -39% no alcance e -9% nas interações, com 4 publicações no mês e taxa de engajamento de 30%; destaque para o Reels em collab com a Echo;</a:t>
+            </a:r>
+          </a:p>
+        </p:txBody>
+      </p:sp>
+      <p:sp>
+        <p:nvSpPr>
+          <p:cNvPr id="18" name="TextBox 17"/>
+          <p:cNvSpPr txBox="1"/>
+          <p:nvPr/>
+        </p:nvSpPr>
+        <p:spPr>
+          <a:xfrm>
+            <a:off x="6467475" y="1978819"/>
+            <a:ext cx="5513642" cy="297656"/>
           </a:xfrm>
           <a:prstGeom prst="rect">
             <a:avLst/>
@@ -27589,35 +27738,44 @@
               </a:lnSpc>
             </a:pPr>
             <a:r>
+              <a:rPr sz="850" b="0" i="0">
+                <a:solidFill>
+                  <a:srgbClr val="000000"/>
+                </a:solidFill>
+                <a:latin typeface="Montserrat"/>
+              </a:rPr>
+              <a:t>• </a:t>
+            </a:r>
+            <a:r>
               <a:rPr sz="850" b="1" i="0">
                 <a:solidFill>
                   <a:srgbClr val="000000"/>
                 </a:solidFill>
                 <a:latin typeface="Montserrat"/>
               </a:rPr>
-              <a:t>Alcance e Interações</a:t>
-            </a:r>
-            <a:r>
-              <a:rPr sz="850" b="1" i="0">
-                <a:solidFill>
-                  <a:srgbClr val="000000"/>
-                </a:solidFill>
-                <a:latin typeface="Montserrat"/>
-              </a:rPr>
-              <a:t>Crescimento de Seguidores:</a:t>
-            </a:r>
-          </a:p>
-        </p:txBody>
-      </p:sp>
-      <p:sp>
-        <p:nvSpPr>
-          <p:cNvPr id="15" name="TextBox 14"/>
-          <p:cNvSpPr txBox="1"/>
-          <p:nvPr/>
-        </p:nvSpPr>
-        <p:spPr>
-          <a:xfrm>
-            <a:off x="6467475" y="1574006"/>
+              <a:t>LinkedIn:</a:t>
+            </a:r>
+            <a:r>
+              <a:rPr sz="850" b="0" i="0">
+                <a:solidFill>
+                  <a:srgbClr val="000000"/>
+                </a:solidFill>
+                <a:latin typeface="Montserrat"/>
+              </a:rPr>
+              <a:t> +58% nos visitantes únicos, mesmo sem publicações, mantendo o papel institucional do canal.</a:t>
+            </a:r>
+          </a:p>
+        </p:txBody>
+      </p:sp>
+      <p:sp>
+        <p:nvSpPr>
+          <p:cNvPr id="19" name="TextBox 18"/>
+          <p:cNvSpPr txBox="1"/>
+          <p:nvPr/>
+        </p:nvSpPr>
+        <p:spPr>
+          <a:xfrm>
+            <a:off x="6467475" y="2547938"/>
             <a:ext cx="5513642" cy="297656"/>
           </a:xfrm>
           <a:prstGeom prst="rect">
@@ -27661,20 +27819,20 @@
                 </a:solidFill>
                 <a:latin typeface="Montserrat"/>
               </a:rPr>
-              <a:t> -39% no alcance e -9% nas interações, com 4 publicações no mês e taxa de engajamento de 30%; destaque para o Reels em collab com a Echo;</a:t>
-            </a:r>
-          </a:p>
-        </p:txBody>
-      </p:sp>
-      <p:sp>
-        <p:nvSpPr>
-          <p:cNvPr id="16" name="TextBox 15"/>
-          <p:cNvSpPr txBox="1"/>
-          <p:nvPr/>
-        </p:nvSpPr>
-        <p:spPr>
-          <a:xfrm>
-            <a:off x="6467475" y="1978819"/>
+              <a:t> saldo de -33 seguidores, encerrando o período com 20.369 seguidores e taxa de retenção de -6%;</a:t>
+            </a:r>
+          </a:p>
+        </p:txBody>
+      </p:sp>
+      <p:sp>
+        <p:nvSpPr>
+          <p:cNvPr id="20" name="TextBox 19"/>
+          <p:cNvSpPr txBox="1"/>
+          <p:nvPr/>
+        </p:nvSpPr>
+        <p:spPr>
+          <a:xfrm>
+            <a:off x="6467475" y="2952750"/>
             <a:ext cx="5513642" cy="297656"/>
           </a:xfrm>
           <a:prstGeom prst="rect">
@@ -27718,120 +27876,6 @@
                 </a:solidFill>
                 <a:latin typeface="Montserrat"/>
               </a:rPr>
-              <a:t> +58% nos visitantes únicos, mesmo sem publicações, mantendo o papel institucional do canal.</a:t>
-            </a:r>
-          </a:p>
-        </p:txBody>
-      </p:sp>
-      <p:sp>
-        <p:nvSpPr>
-          <p:cNvPr id="17" name="TextBox 16"/>
-          <p:cNvSpPr txBox="1"/>
-          <p:nvPr/>
-        </p:nvSpPr>
-        <p:spPr>
-          <a:xfrm>
-            <a:off x="6467475" y="2547938"/>
-            <a:ext cx="5513642" cy="297656"/>
-          </a:xfrm>
-          <a:prstGeom prst="rect">
-            <a:avLst/>
-          </a:prstGeom>
-          <a:noFill/>
-        </p:spPr>
-        <p:txBody>
-          <a:bodyPr wrap="square" lIns="0" rIns="0" tIns="0" bIns="0" anchor="t">
-            <a:noAutofit/>
-          </a:bodyPr>
-          <a:lstStyle/>
-          <a:p>
-            <a:pPr algn="l">
-              <a:lnSpc>
-                <a:spcPts val="1293"/>
-              </a:lnSpc>
-            </a:pPr>
-            <a:r>
-              <a:rPr sz="850" b="0" i="0">
-                <a:solidFill>
-                  <a:srgbClr val="000000"/>
-                </a:solidFill>
-                <a:latin typeface="Montserrat"/>
-              </a:rPr>
-              <a:t>• </a:t>
-            </a:r>
-            <a:r>
-              <a:rPr sz="850" b="1" i="0">
-                <a:solidFill>
-                  <a:srgbClr val="000000"/>
-                </a:solidFill>
-                <a:latin typeface="Montserrat"/>
-              </a:rPr>
-              <a:t>Instagram:</a:t>
-            </a:r>
-            <a:r>
-              <a:rPr sz="850" b="0" i="0">
-                <a:solidFill>
-                  <a:srgbClr val="000000"/>
-                </a:solidFill>
-                <a:latin typeface="Montserrat"/>
-              </a:rPr>
-              <a:t> saldo de -33 seguidores, encerrando o período com 20.369 seguidores e taxa de retenção de -6%;</a:t>
-            </a:r>
-          </a:p>
-        </p:txBody>
-      </p:sp>
-      <p:sp>
-        <p:nvSpPr>
-          <p:cNvPr id="18" name="TextBox 17"/>
-          <p:cNvSpPr txBox="1"/>
-          <p:nvPr/>
-        </p:nvSpPr>
-        <p:spPr>
-          <a:xfrm>
-            <a:off x="6467475" y="2952750"/>
-            <a:ext cx="5513642" cy="297656"/>
-          </a:xfrm>
-          <a:prstGeom prst="rect">
-            <a:avLst/>
-          </a:prstGeom>
-          <a:noFill/>
-        </p:spPr>
-        <p:txBody>
-          <a:bodyPr wrap="square" lIns="0" rIns="0" tIns="0" bIns="0" anchor="t">
-            <a:noAutofit/>
-          </a:bodyPr>
-          <a:lstStyle/>
-          <a:p>
-            <a:pPr algn="l">
-              <a:lnSpc>
-                <a:spcPts val="1293"/>
-              </a:lnSpc>
-            </a:pPr>
-            <a:r>
-              <a:rPr sz="850" b="0" i="0">
-                <a:solidFill>
-                  <a:srgbClr val="000000"/>
-                </a:solidFill>
-                <a:latin typeface="Montserrat"/>
-              </a:rPr>
-              <a:t>• </a:t>
-            </a:r>
-            <a:r>
-              <a:rPr sz="850" b="1" i="0">
-                <a:solidFill>
-                  <a:srgbClr val="000000"/>
-                </a:solidFill>
-                <a:latin typeface="Montserrat"/>
-              </a:rPr>
-              <a:t>LinkedIn:</a:t>
-            </a:r>
-            <a:r>
-              <a:rPr sz="850" b="0" i="0">
-                <a:solidFill>
-                  <a:srgbClr val="000000"/>
-                </a:solidFill>
-                <a:latin typeface="Montserrat"/>
-              </a:rPr>
               <a:t> +20 novos seguidores, finalizando o período com 17.237 seguidores e taxa de retenção de 20%.</a:t>
             </a:r>
           </a:p>
@@ -27839,7 +27883,7 @@
       </p:sp>
       <p:sp>
         <p:nvSpPr>
-          <p:cNvPr id="19" name="TextBox 18"/>
+          <p:cNvPr id="21" name="TextBox 20"/>
           <p:cNvSpPr txBox="1"/>
           <p:nvPr/>
         </p:nvSpPr>
@@ -27874,7 +27918,7 @@
       </p:sp>
       <p:sp>
         <p:nvSpPr>
-          <p:cNvPr id="20" name="TextBox 19"/>
+          <p:cNvPr id="22" name="TextBox 21"/>
           <p:cNvSpPr txBox="1"/>
           <p:nvPr/>
         </p:nvSpPr>
@@ -27927,7 +27971,7 @@
       </p:sp>
       <p:sp>
         <p:nvSpPr>
-          <p:cNvPr id="21" name="TextBox 20"/>
+          <p:cNvPr id="23" name="TextBox 22"/>
           <p:cNvSpPr txBox="1"/>
           <p:nvPr/>
         </p:nvSpPr>
@@ -27980,7 +28024,7 @@
       </p:sp>
       <p:sp>
         <p:nvSpPr>
-          <p:cNvPr id="22" name="TextBox 21"/>
+          <p:cNvPr id="24" name="TextBox 23"/>
           <p:cNvSpPr txBox="1"/>
           <p:nvPr/>
         </p:nvSpPr>
@@ -28033,7 +28077,7 @@
       </p:sp>
       <p:sp>
         <p:nvSpPr>
-          <p:cNvPr id="23" name="TextBox 22"/>
+          <p:cNvPr id="25" name="TextBox 24"/>
           <p:cNvSpPr txBox="1"/>
           <p:nvPr/>
         </p:nvSpPr>

</xml_diff>